<commit_message>
Fixed Ops Headcount: 2025 Jan-Dec vs 2026 chart like the other YOY slides; trend renderer can hide point labels
Co-Authored-By: Claude Opus 5.5 <noreply@anthropic.com>
Claude-Session: https://claude.ai/code/session_01Xa4nFVxuQGXmHARGph9WhS
</commit_message>
<xml_diff>
--- a/day2-deck/decks/Fixed Ops Productivity - House Style.pptx
+++ b/day2-deck/decks/Fixed Ops Productivity - House Style.pptx
@@ -4817,7 +4817,7 @@
               <c:strCache>
                 <c:ptCount val="1"/>
                 <c:pt idx="0">
-                  <c:v>Fixed employees, trailing 12 months</c:v>
+                  <c:v>2026</c:v>
                 </c:pt>
               </c:strCache>
             </c:strRef>
@@ -4852,9 +4852,8 @@
                 </a:pPr>
               </a:p>
             </c:txPr>
-            <c:dLblPos val="t"/>
             <c:showLegendKey val="0"/>
-            <c:showVal val="1"/>
+            <c:showVal val="0"/>
             <c:showCatName val="0"/>
             <c:showSerName val="0"/>
             <c:showPercent val="0"/>
@@ -4868,7 +4867,7 @@
               <a:solidFill>
                 <a:srgbClr val="2587C5"/>
               </a:solidFill>
-              <a:ln w="12700" cap="flat">
+              <a:ln w="9525" cap="flat">
                 <a:solidFill>
                   <a:srgbClr val="2587C5"/>
                 </a:solidFill>
@@ -4885,40 +4884,40 @@
                 <c:ptCount val="12"/>
                 <c:lvl>
                   <c:pt idx="0">
-                    <c:v>Oct '25</c:v>
+                    <c:v>Jan</c:v>
                   </c:pt>
                   <c:pt idx="1">
-                    <c:v>Nov '25</c:v>
+                    <c:v>Feb</c:v>
                   </c:pt>
                   <c:pt idx="2">
-                    <c:v>Dec '25</c:v>
+                    <c:v>Mar</c:v>
                   </c:pt>
                   <c:pt idx="3">
-                    <c:v>Jan '26</c:v>
+                    <c:v>Apr</c:v>
                   </c:pt>
                   <c:pt idx="4">
-                    <c:v>Feb '26</c:v>
+                    <c:v>May</c:v>
                   </c:pt>
                   <c:pt idx="5">
-                    <c:v>Mar '26</c:v>
+                    <c:v>Jun</c:v>
                   </c:pt>
                   <c:pt idx="6">
-                    <c:v>Apr '26</c:v>
+                    <c:v>Jul</c:v>
                   </c:pt>
                   <c:pt idx="7">
-                    <c:v>May '26</c:v>
+                    <c:v>Aug</c:v>
                   </c:pt>
                   <c:pt idx="8">
-                    <c:v>Jun '26</c:v>
+                    <c:v>Sep</c:v>
                   </c:pt>
                   <c:pt idx="9">
-                    <c:v>Jul '26</c:v>
+                    <c:v>Oct</c:v>
                   </c:pt>
                   <c:pt idx="10">
-                    <c:v>Aug '26</c:v>
+                    <c:v>Nov</c:v>
                   </c:pt>
                   <c:pt idx="11">
-                    <c:v>Sep '26</c:v>
+                    <c:v>Dec</c:v>
                   </c:pt>
                 </c:lvl>
               </c:multiLvlStrCache>
@@ -4931,40 +4930,651 @@
                 <c:formatCode>General</c:formatCode>
                 <c:ptCount val="12"/>
                 <c:pt idx="0">
+                  <c:v>1530</c:v>
+                </c:pt>
+                <c:pt idx="1">
+                  <c:v>1530</c:v>
+                </c:pt>
+                <c:pt idx="2">
+                  <c:v>1540</c:v>
+                </c:pt>
+                <c:pt idx="3">
+                  <c:v>1545</c:v>
+                </c:pt>
+                <c:pt idx="4">
+                  <c:v>1537</c:v>
+                </c:pt>
+                <c:pt idx="5">
+                  <c:v>1546</c:v>
+                </c:pt>
+                <c:pt idx="6">
+                  <c:v>1548</c:v>
+                </c:pt>
+                <c:pt idx="7">
+                  <c:v>1549</c:v>
+                </c:pt>
+                <c:pt idx="8">
+                  <c:v>1540</c:v>
+                </c:pt>
+                <c:pt idx="9">
+                  <c:v/>
+                </c:pt>
+                <c:pt idx="10">
+                  <c:v/>
+                </c:pt>
+                <c:pt idx="11">
+                  <c:v/>
+                </c:pt>
+              </c:numCache>
+            </c:numRef>
+          </c:val>
+          <c:smooth val="0"/>
+        </c:ser>
+        <c:dLbls>
+          <c:numFmt formatCode="#,##0" sourceLinked="0"/>
+          <c:txPr>
+            <a:bodyPr/>
+            <a:lstStyle/>
+            <a:p>
+              <a:pPr>
+                <a:defRPr b="0" i="0" strike="noStrike" sz="1400" u="none">
+                  <a:solidFill>
+                    <a:srgbClr val="1A1A1A"/>
+                  </a:solidFill>
+                  <a:latin typeface="+mn-lt"/>
+                </a:defRPr>
+              </a:pPr>
+            </a:p>
+          </c:txPr>
+          <c:showLegendKey val="0"/>
+          <c:showVal val="0"/>
+          <c:showCatName val="0"/>
+          <c:showSerName val="0"/>
+          <c:showPercent val="0"/>
+          <c:showBubbleSize val="0"/>
+          <c:showLeaderLines val="0"/>
+        </c:dLbls>
+        <c:marker val="1"/>
+        <c:axId val="2094734554"/>
+        <c:axId val="2094734552"/>
+        <c:axId val="2094734556"/>
+      </c:lineChart>
+      <c:catAx>
+        <c:axId val="2094734554"/>
+        <c:scaling>
+          <c:orientation val="minMax"/>
+        </c:scaling>
+        <c:delete val="0"/>
+        <c:axPos val="b"/>
+        <c:numFmt formatCode="General" sourceLinked="1"/>
+        <c:majorTickMark val="out"/>
+        <c:minorTickMark val="none"/>
+        <c:tickLblPos val="low"/>
+        <c:spPr>
+          <a:ln w="12700" cap="flat">
+            <a:noFill/>
+            <a:prstDash val="solid"/>
+            <a:round/>
+          </a:ln>
+        </c:spPr>
+        <c:txPr>
+          <a:bodyPr/>
+          <a:lstStyle/>
+          <a:p>
+            <a:pPr>
+              <a:defRPr sz="1400" b="0" i="0" u="none" strike="noStrike">
+                <a:solidFill>
+                  <a:srgbClr val="FFFFFF"/>
+                </a:solidFill>
+                <a:latin typeface="+mn-lt"/>
+              </a:defRPr>
+            </a:pPr>
+            <a:endParaRPr lang="en-US"/>
+          </a:p>
+        </c:txPr>
+        <c:crossAx val="2094734552"/>
+        <c:crosses val="min"/>
+        <c:auto val="1"/>
+        <c:lblAlgn val="ctr"/>
+        <c:noMultiLvlLbl val="1"/>
+      </c:catAx>
+      <c:valAx>
+        <c:axId val="2094734552"/>
+        <c:scaling>
+          <c:orientation val="minMax"/>
+          <c:max val="1700"/>
+          <c:min val="1450"/>
+        </c:scaling>
+        <c:delete val="0"/>
+        <c:axPos val="l"/>
+        <c:numFmt formatCode="#,##0" sourceLinked="0"/>
+        <c:majorTickMark val="out"/>
+        <c:minorTickMark val="none"/>
+        <c:tickLblPos val="nextTo"/>
+        <c:spPr>
+          <a:ln w="12700" cap="flat">
+            <a:noFill/>
+            <a:prstDash val="solid"/>
+            <a:round/>
+          </a:ln>
+        </c:spPr>
+        <c:txPr>
+          <a:bodyPr/>
+          <a:lstStyle/>
+          <a:p>
+            <a:pPr>
+              <a:defRPr sz="1400" b="0" i="0" u="none" strike="noStrike">
+                <a:solidFill>
+                  <a:srgbClr val="FFFFFF"/>
+                </a:solidFill>
+                <a:latin typeface="+mn-lt"/>
+              </a:defRPr>
+            </a:pPr>
+            <a:endParaRPr lang="en-US"/>
+          </a:p>
+        </c:txPr>
+        <c:crossAx val="2094734554"/>
+        <c:crosses val="autoZero"/>
+        <c:crossBetween val="between"/>
+        <c:majorUnit val="50"/>
+      </c:valAx>
+      <c:spPr>
+        <a:noFill/>
+        <a:ln>
+          <a:noFill/>
+        </a:ln>
+        <a:effectLst/>
+      </c:spPr>
+    </c:plotArea>
+    <c:plotVisOnly val="1"/>
+    <c:dispBlanksAs val="span"/>
+  </c:chart>
+  <c:spPr>
+    <a:noFill/>
+    <a:ln>
+      <a:noFill/>
+    </a:ln>
+    <a:effectLst/>
+  </c:spPr>
+  <c:externalData r:id="rId1">
+    <c:autoUpdate val="0"/>
+  </c:externalData>
+</c:chartSpace>
+</file>
+
+<file path=ppt/charts/chart24.xml><?xml version="1.0" encoding="utf-8"?>
+<c:chartSpace xmlns:c="http://schemas.openxmlformats.org/drawingml/2006/chart" xmlns:a="http://schemas.openxmlformats.org/drawingml/2006/main" xmlns:r="http://schemas.openxmlformats.org/officeDocument/2006/relationships">
+  <c:date1904 val="0"/>
+  <c:roundedCorners val="1"/>
+  <c:chart>
+    <c:autoTitleDeleted val="1"/>
+    <c:plotArea>
+      <c:layout/>
+      <c:lineChart>
+        <c:varyColors val="0"/>
+        <c:ser>
+          <c:idx val="0"/>
+          <c:order val="0"/>
+          <c:tx>
+            <c:strRef>
+              <c:f>Sheet1!$B$1</c:f>
+              <c:strCache>
+                <c:ptCount val="1"/>
+                <c:pt idx="0">
+                  <c:v>2026</c:v>
+                </c:pt>
+              </c:strCache>
+            </c:strRef>
+          </c:tx>
+          <c:spPr>
+            <a:solidFill>
+              <a:srgbClr val="2587C5"/>
+            </a:solidFill>
+            <a:ln>
+              <a:noFill/>
+            </a:ln>
+            <a:effectLst/>
+          </c:spPr>
+          <c:invertIfNegative val="0"/>
+          <c:dLbls>
+            <c:numFmt formatCode="#,##0" sourceLinked="0"/>
+            <c:txPr>
+              <a:bodyPr/>
+              <a:lstStyle/>
+              <a:p>
+                <a:pPr>
+                  <a:defRPr b="0" i="0" strike="noStrike" sz="1400" u="none">
+                    <a:solidFill>
+                      <a:srgbClr val="1A1A1A"/>
+                    </a:solidFill>
+                    <a:latin typeface="+mn-lt"/>
+                  </a:defRPr>
+                </a:pPr>
+              </a:p>
+            </c:txPr>
+            <c:dLblPos val="b"/>
+            <c:showLegendKey val="0"/>
+            <c:showVal val="1"/>
+            <c:showCatName val="0"/>
+            <c:showSerName val="0"/>
+            <c:showPercent val="0"/>
+            <c:showBubbleSize val="0"/>
+            <c:showLeaderLines val="0"/>
+          </c:dLbls>
+          <c:marker>
+            <c:symbol val="none"/>
+            <c:size val="8"/>
+            <c:spPr>
+              <a:solidFill>
+                <a:srgbClr val="2587C5"/>
+              </a:solidFill>
+              <a:ln w="9525" cap="flat">
+                <a:solidFill>
+                  <a:srgbClr val="2587C5"/>
+                </a:solidFill>
+                <a:prstDash val="solid"/>
+                <a:round/>
+              </a:ln>
+              <a:effectLst/>
+            </c:spPr>
+          </c:marker>
+          <c:cat>
+            <c:multiLvlStrRef>
+              <c:f>Sheet1!$A$2:$A$13</c:f>
+              <c:multiLvlStrCache>
+                <c:ptCount val="12"/>
+                <c:lvl>
+                  <c:pt idx="0">
+                    <c:v>Jan</c:v>
+                  </c:pt>
+                  <c:pt idx="1">
+                    <c:v>Feb</c:v>
+                  </c:pt>
+                  <c:pt idx="2">
+                    <c:v>Mar</c:v>
+                  </c:pt>
+                  <c:pt idx="3">
+                    <c:v>Apr</c:v>
+                  </c:pt>
+                  <c:pt idx="4">
+                    <c:v>May</c:v>
+                  </c:pt>
+                  <c:pt idx="5">
+                    <c:v>Jun</c:v>
+                  </c:pt>
+                  <c:pt idx="6">
+                    <c:v>Jul</c:v>
+                  </c:pt>
+                  <c:pt idx="7">
+                    <c:v>Aug</c:v>
+                  </c:pt>
+                  <c:pt idx="8">
+                    <c:v>Sep</c:v>
+                  </c:pt>
+                  <c:pt idx="9">
+                    <c:v>Oct</c:v>
+                  </c:pt>
+                  <c:pt idx="10">
+                    <c:v>Nov</c:v>
+                  </c:pt>
+                  <c:pt idx="11">
+                    <c:v>Dec</c:v>
+                  </c:pt>
+                </c:lvl>
+              </c:multiLvlStrCache>
+            </c:multiLvlStrRef>
+          </c:cat>
+          <c:val>
+            <c:numRef>
+              <c:f>Sheet1!$B$2:$B$13</c:f>
+              <c:numCache>
+                <c:formatCode>General</c:formatCode>
+                <c:ptCount val="12"/>
+                <c:pt idx="0">
+                  <c:v>1530</c:v>
+                </c:pt>
+                <c:pt idx="1">
+                  <c:v>1530</c:v>
+                </c:pt>
+                <c:pt idx="2">
+                  <c:v>1540</c:v>
+                </c:pt>
+                <c:pt idx="3">
+                  <c:v>1545</c:v>
+                </c:pt>
+                <c:pt idx="4">
+                  <c:v>1537</c:v>
+                </c:pt>
+                <c:pt idx="5">
+                  <c:v>1546</c:v>
+                </c:pt>
+                <c:pt idx="6">
+                  <c:v>1548</c:v>
+                </c:pt>
+                <c:pt idx="7">
+                  <c:v>1549</c:v>
+                </c:pt>
+                <c:pt idx="8">
+                  <c:v>1540</c:v>
+                </c:pt>
+                <c:pt idx="9">
+                  <c:v/>
+                </c:pt>
+                <c:pt idx="10">
+                  <c:v/>
+                </c:pt>
+                <c:pt idx="11">
+                  <c:v/>
+                </c:pt>
+              </c:numCache>
+            </c:numRef>
+          </c:val>
+          <c:smooth val="0"/>
+        </c:ser>
+        <c:dLbls>
+          <c:numFmt formatCode="#,##0" sourceLinked="0"/>
+          <c:txPr>
+            <a:bodyPr/>
+            <a:lstStyle/>
+            <a:p>
+              <a:pPr>
+                <a:defRPr b="0" i="0" strike="noStrike" sz="1400" u="none">
+                  <a:solidFill>
+                    <a:srgbClr val="1A1A1A"/>
+                  </a:solidFill>
+                  <a:latin typeface="+mn-lt"/>
+                </a:defRPr>
+              </a:pPr>
+            </a:p>
+          </c:txPr>
+          <c:dLblPos val="b"/>
+          <c:showLegendKey val="0"/>
+          <c:showVal val="1"/>
+          <c:showCatName val="0"/>
+          <c:showSerName val="0"/>
+          <c:showPercent val="0"/>
+          <c:showBubbleSize val="0"/>
+          <c:showLeaderLines val="0"/>
+        </c:dLbls>
+        <c:marker val="1"/>
+        <c:axId val="2094734554"/>
+        <c:axId val="2094734552"/>
+        <c:axId val="2094734556"/>
+      </c:lineChart>
+      <c:catAx>
+        <c:axId val="2094734554"/>
+        <c:scaling>
+          <c:orientation val="minMax"/>
+        </c:scaling>
+        <c:delete val="0"/>
+        <c:axPos val="b"/>
+        <c:numFmt formatCode="General" sourceLinked="1"/>
+        <c:majorTickMark val="out"/>
+        <c:minorTickMark val="none"/>
+        <c:tickLblPos val="low"/>
+        <c:spPr>
+          <a:ln w="12700" cap="flat">
+            <a:noFill/>
+            <a:prstDash val="solid"/>
+            <a:round/>
+          </a:ln>
+        </c:spPr>
+        <c:txPr>
+          <a:bodyPr/>
+          <a:lstStyle/>
+          <a:p>
+            <a:pPr>
+              <a:defRPr sz="1400" b="0" i="0" u="none" strike="noStrike">
+                <a:solidFill>
+                  <a:srgbClr val="FFFFFF"/>
+                </a:solidFill>
+                <a:latin typeface="+mn-lt"/>
+              </a:defRPr>
+            </a:pPr>
+            <a:endParaRPr lang="en-US"/>
+          </a:p>
+        </c:txPr>
+        <c:crossAx val="2094734552"/>
+        <c:crosses val="min"/>
+        <c:auto val="1"/>
+        <c:lblAlgn val="ctr"/>
+        <c:noMultiLvlLbl val="1"/>
+      </c:catAx>
+      <c:valAx>
+        <c:axId val="2094734552"/>
+        <c:scaling>
+          <c:orientation val="minMax"/>
+          <c:max val="1700"/>
+          <c:min val="1450"/>
+        </c:scaling>
+        <c:delete val="0"/>
+        <c:axPos val="l"/>
+        <c:numFmt formatCode="#,##0" sourceLinked="0"/>
+        <c:majorTickMark val="out"/>
+        <c:minorTickMark val="none"/>
+        <c:tickLblPos val="nextTo"/>
+        <c:spPr>
+          <a:ln w="12700" cap="flat">
+            <a:noFill/>
+            <a:prstDash val="solid"/>
+            <a:round/>
+          </a:ln>
+        </c:spPr>
+        <c:txPr>
+          <a:bodyPr/>
+          <a:lstStyle/>
+          <a:p>
+            <a:pPr>
+              <a:defRPr sz="1400" b="0" i="0" u="none" strike="noStrike">
+                <a:solidFill>
+                  <a:srgbClr val="FFFFFF"/>
+                </a:solidFill>
+                <a:latin typeface="+mn-lt"/>
+              </a:defRPr>
+            </a:pPr>
+            <a:endParaRPr lang="en-US"/>
+          </a:p>
+        </c:txPr>
+        <c:crossAx val="2094734554"/>
+        <c:crosses val="autoZero"/>
+        <c:crossBetween val="between"/>
+        <c:majorUnit val="50"/>
+      </c:valAx>
+      <c:spPr>
+        <a:solidFill>
+          <a:srgbClr val="FFFFFF">
+            <a:alpha val="0"/>
+          </a:srgbClr>
+        </a:solidFill>
+        <a:ln>
+          <a:noFill/>
+        </a:ln>
+        <a:effectLst/>
+      </c:spPr>
+    </c:plotArea>
+    <c:plotVisOnly val="1"/>
+    <c:dispBlanksAs val="span"/>
+  </c:chart>
+  <c:spPr>
+    <a:solidFill>
+      <a:srgbClr val="FFFFFF">
+        <a:alpha val="0"/>
+      </a:srgbClr>
+    </a:solidFill>
+    <a:ln>
+      <a:noFill/>
+    </a:ln>
+    <a:effectLst/>
+  </c:spPr>
+  <c:externalData r:id="rId1">
+    <c:autoUpdate val="0"/>
+  </c:externalData>
+</c:chartSpace>
+</file>
+
+<file path=ppt/charts/chart25.xml><?xml version="1.0" encoding="utf-8"?>
+<c:chartSpace xmlns:c="http://schemas.openxmlformats.org/drawingml/2006/chart" xmlns:a="http://schemas.openxmlformats.org/drawingml/2006/main" xmlns:r="http://schemas.openxmlformats.org/officeDocument/2006/relationships">
+  <c:date1904 val="0"/>
+  <c:roundedCorners val="1"/>
+  <c:chart>
+    <c:autoTitleDeleted val="1"/>
+    <c:plotArea>
+      <c:layout/>
+      <c:lineChart>
+        <c:varyColors val="0"/>
+        <c:ser>
+          <c:idx val="0"/>
+          <c:order val="0"/>
+          <c:tx>
+            <c:strRef>
+              <c:f>Sheet1!$B$1</c:f>
+              <c:strCache>
+                <c:ptCount val="1"/>
+                <c:pt idx="0">
+                  <c:v>2025</c:v>
+                </c:pt>
+              </c:strCache>
+            </c:strRef>
+          </c:tx>
+          <c:spPr>
+            <a:solidFill>
+              <a:srgbClr val="9AA3AD"/>
+            </a:solidFill>
+            <a:ln>
+              <a:noFill/>
+            </a:ln>
+            <a:effectLst/>
+          </c:spPr>
+          <c:invertIfNegative val="0"/>
+          <c:dLbls>
+            <c:numFmt formatCode="#,##0" sourceLinked="0"/>
+            <c:txPr>
+              <a:bodyPr/>
+              <a:lstStyle/>
+              <a:p>
+                <a:pPr>
+                  <a:defRPr b="0" i="0" strike="noStrike" sz="1400" u="none">
+                    <a:solidFill>
+                      <a:srgbClr val="1A1A1A"/>
+                    </a:solidFill>
+                    <a:latin typeface="+mn-lt"/>
+                  </a:defRPr>
+                </a:pPr>
+              </a:p>
+            </c:txPr>
+            <c:dLblPos val="t"/>
+            <c:showLegendKey val="0"/>
+            <c:showVal val="1"/>
+            <c:showCatName val="0"/>
+            <c:showSerName val="0"/>
+            <c:showPercent val="0"/>
+            <c:showBubbleSize val="0"/>
+            <c:showLeaderLines val="0"/>
+          </c:dLbls>
+          <c:marker>
+            <c:symbol val="none"/>
+            <c:size val="8"/>
+            <c:spPr>
+              <a:solidFill>
+                <a:srgbClr val="9AA3AD"/>
+              </a:solidFill>
+              <a:ln w="9525" cap="flat">
+                <a:solidFill>
+                  <a:srgbClr val="9AA3AD"/>
+                </a:solidFill>
+                <a:prstDash val="solid"/>
+                <a:round/>
+              </a:ln>
+              <a:effectLst/>
+            </c:spPr>
+          </c:marker>
+          <c:cat>
+            <c:multiLvlStrRef>
+              <c:f>Sheet1!$A$2:$A$13</c:f>
+              <c:multiLvlStrCache>
+                <c:ptCount val="12"/>
+                <c:lvl>
+                  <c:pt idx="0">
+                    <c:v>Jan</c:v>
+                  </c:pt>
+                  <c:pt idx="1">
+                    <c:v>Feb</c:v>
+                  </c:pt>
+                  <c:pt idx="2">
+                    <c:v>Mar</c:v>
+                  </c:pt>
+                  <c:pt idx="3">
+                    <c:v>Apr</c:v>
+                  </c:pt>
+                  <c:pt idx="4">
+                    <c:v>May</c:v>
+                  </c:pt>
+                  <c:pt idx="5">
+                    <c:v>Jun</c:v>
+                  </c:pt>
+                  <c:pt idx="6">
+                    <c:v>Jul</c:v>
+                  </c:pt>
+                  <c:pt idx="7">
+                    <c:v>Aug</c:v>
+                  </c:pt>
+                  <c:pt idx="8">
+                    <c:v>Sep</c:v>
+                  </c:pt>
+                  <c:pt idx="9">
+                    <c:v>Oct</c:v>
+                  </c:pt>
+                  <c:pt idx="10">
+                    <c:v>Nov</c:v>
+                  </c:pt>
+                  <c:pt idx="11">
+                    <c:v>Dec</c:v>
+                  </c:pt>
+                </c:lvl>
+              </c:multiLvlStrCache>
+            </c:multiLvlStrRef>
+          </c:cat>
+          <c:val>
+            <c:numRef>
+              <c:f>Sheet1!$B$2:$B$13</c:f>
+              <c:numCache>
+                <c:formatCode>General</c:formatCode>
+                <c:ptCount val="12"/>
+                <c:pt idx="0">
+                  <c:v>1625</c:v>
+                </c:pt>
+                <c:pt idx="1">
+                  <c:v>1632</c:v>
+                </c:pt>
+                <c:pt idx="2">
+                  <c:v>1629</c:v>
+                </c:pt>
+                <c:pt idx="3">
+                  <c:v>1615</c:v>
+                </c:pt>
+                <c:pt idx="4">
+                  <c:v>1623</c:v>
+                </c:pt>
+                <c:pt idx="5">
+                  <c:v>1616</c:v>
+                </c:pt>
+                <c:pt idx="6">
+                  <c:v>1629</c:v>
+                </c:pt>
+                <c:pt idx="7">
+                  <c:v>1627</c:v>
+                </c:pt>
+                <c:pt idx="8">
+                  <c:v>1616</c:v>
+                </c:pt>
+                <c:pt idx="9">
                   <c:v>1604</c:v>
                 </c:pt>
-                <c:pt idx="1">
+                <c:pt idx="10">
                   <c:v>1582</c:v>
                 </c:pt>
-                <c:pt idx="2">
+                <c:pt idx="11">
                   <c:v>1563</c:v>
-                </c:pt>
-                <c:pt idx="3">
-                  <c:v>1530</c:v>
-                </c:pt>
-                <c:pt idx="4">
-                  <c:v>1530</c:v>
-                </c:pt>
-                <c:pt idx="5">
-                  <c:v>1540</c:v>
-                </c:pt>
-                <c:pt idx="6">
-                  <c:v>1545</c:v>
-                </c:pt>
-                <c:pt idx="7">
-                  <c:v>1537</c:v>
-                </c:pt>
-                <c:pt idx="8">
-                  <c:v>1546</c:v>
-                </c:pt>
-                <c:pt idx="9">
-                  <c:v>1548</c:v>
-                </c:pt>
-                <c:pt idx="10">
-                  <c:v>1549</c:v>
-                </c:pt>
-                <c:pt idx="11">
-                  <c:v>1540</c:v>
                 </c:pt>
               </c:numCache>
             </c:numRef>
@@ -5014,6 +5624,318 @@
         <c:tickLblPos val="low"/>
         <c:spPr>
           <a:ln w="12700" cap="flat">
+            <a:noFill/>
+            <a:prstDash val="solid"/>
+            <a:round/>
+          </a:ln>
+        </c:spPr>
+        <c:txPr>
+          <a:bodyPr/>
+          <a:lstStyle/>
+          <a:p>
+            <a:pPr>
+              <a:defRPr sz="1400" b="0" i="0" u="none" strike="noStrike">
+                <a:solidFill>
+                  <a:srgbClr val="FFFFFF"/>
+                </a:solidFill>
+                <a:latin typeface="+mn-lt"/>
+              </a:defRPr>
+            </a:pPr>
+            <a:endParaRPr lang="en-US"/>
+          </a:p>
+        </c:txPr>
+        <c:crossAx val="2094734552"/>
+        <c:crosses val="min"/>
+        <c:auto val="1"/>
+        <c:lblAlgn val="ctr"/>
+        <c:noMultiLvlLbl val="1"/>
+      </c:catAx>
+      <c:valAx>
+        <c:axId val="2094734552"/>
+        <c:scaling>
+          <c:orientation val="minMax"/>
+          <c:max val="1700"/>
+          <c:min val="1450"/>
+        </c:scaling>
+        <c:delete val="0"/>
+        <c:axPos val="l"/>
+        <c:numFmt formatCode="#,##0" sourceLinked="0"/>
+        <c:majorTickMark val="out"/>
+        <c:minorTickMark val="none"/>
+        <c:tickLblPos val="nextTo"/>
+        <c:spPr>
+          <a:ln w="12700" cap="flat">
+            <a:noFill/>
+            <a:prstDash val="solid"/>
+            <a:round/>
+          </a:ln>
+        </c:spPr>
+        <c:txPr>
+          <a:bodyPr/>
+          <a:lstStyle/>
+          <a:p>
+            <a:pPr>
+              <a:defRPr sz="1400" b="0" i="0" u="none" strike="noStrike">
+                <a:solidFill>
+                  <a:srgbClr val="FFFFFF"/>
+                </a:solidFill>
+                <a:latin typeface="+mn-lt"/>
+              </a:defRPr>
+            </a:pPr>
+            <a:endParaRPr lang="en-US"/>
+          </a:p>
+        </c:txPr>
+        <c:crossAx val="2094734554"/>
+        <c:crosses val="autoZero"/>
+        <c:crossBetween val="between"/>
+        <c:majorUnit val="50"/>
+      </c:valAx>
+      <c:spPr>
+        <a:solidFill>
+          <a:srgbClr val="FFFFFF">
+            <a:alpha val="0"/>
+          </a:srgbClr>
+        </a:solidFill>
+        <a:ln>
+          <a:noFill/>
+        </a:ln>
+        <a:effectLst/>
+      </c:spPr>
+    </c:plotArea>
+    <c:plotVisOnly val="1"/>
+    <c:dispBlanksAs val="span"/>
+  </c:chart>
+  <c:spPr>
+    <a:solidFill>
+      <a:srgbClr val="FFFFFF">
+        <a:alpha val="0"/>
+      </a:srgbClr>
+    </a:solidFill>
+    <a:ln>
+      <a:noFill/>
+    </a:ln>
+    <a:effectLst/>
+  </c:spPr>
+  <c:externalData r:id="rId1">
+    <c:autoUpdate val="0"/>
+  </c:externalData>
+</c:chartSpace>
+</file>
+
+<file path=ppt/charts/chart26.xml><?xml version="1.0" encoding="utf-8"?>
+<c:chartSpace xmlns:c="http://schemas.openxmlformats.org/drawingml/2006/chart" xmlns:a="http://schemas.openxmlformats.org/drawingml/2006/main" xmlns:r="http://schemas.openxmlformats.org/officeDocument/2006/relationships">
+  <c:date1904 val="0"/>
+  <c:roundedCorners val="1"/>
+  <c:chart>
+    <c:autoTitleDeleted val="1"/>
+    <c:plotArea>
+      <c:layout/>
+      <c:lineChart>
+        <c:varyColors val="0"/>
+        <c:ser>
+          <c:idx val="0"/>
+          <c:order val="0"/>
+          <c:tx>
+            <c:strRef>
+              <c:f>Sheet1!$B$1</c:f>
+              <c:strCache>
+                <c:ptCount val="1"/>
+                <c:pt idx="0">
+                  <c:v>2025</c:v>
+                </c:pt>
+              </c:strCache>
+            </c:strRef>
+          </c:tx>
+          <c:spPr>
+            <a:solidFill>
+              <a:srgbClr val="9AA3AD"/>
+            </a:solidFill>
+            <a:ln w="38100" cap="flat">
+              <a:solidFill>
+                <a:srgbClr val="9AA3AD"/>
+              </a:solidFill>
+              <a:prstDash val="solid"/>
+              <a:round/>
+            </a:ln>
+            <a:effectLst/>
+          </c:spPr>
+          <c:invertIfNegative val="0"/>
+          <c:dLbls>
+            <c:numFmt formatCode="#,##0" sourceLinked="0"/>
+            <c:txPr>
+              <a:bodyPr/>
+              <a:lstStyle/>
+              <a:p>
+                <a:pPr>
+                  <a:defRPr b="0" i="0" strike="noStrike" sz="1400" u="none">
+                    <a:solidFill>
+                      <a:srgbClr val="1A1A1A"/>
+                    </a:solidFill>
+                    <a:latin typeface="+mn-lt"/>
+                  </a:defRPr>
+                </a:pPr>
+              </a:p>
+            </c:txPr>
+            <c:showLegendKey val="0"/>
+            <c:showVal val="0"/>
+            <c:showCatName val="0"/>
+            <c:showSerName val="0"/>
+            <c:showPercent val="0"/>
+            <c:showBubbleSize val="0"/>
+            <c:showLeaderLines val="0"/>
+          </c:dLbls>
+          <c:marker>
+            <c:symbol val="circle"/>
+            <c:size val="8"/>
+            <c:spPr>
+              <a:solidFill>
+                <a:srgbClr val="9AA3AD"/>
+              </a:solidFill>
+              <a:ln w="9525" cap="flat">
+                <a:solidFill>
+                  <a:srgbClr val="9AA3AD"/>
+                </a:solidFill>
+                <a:prstDash val="solid"/>
+                <a:round/>
+              </a:ln>
+              <a:effectLst/>
+            </c:spPr>
+          </c:marker>
+          <c:cat>
+            <c:multiLvlStrRef>
+              <c:f>Sheet1!$A$2:$A$13</c:f>
+              <c:multiLvlStrCache>
+                <c:ptCount val="12"/>
+                <c:lvl>
+                  <c:pt idx="0">
+                    <c:v>Jan</c:v>
+                  </c:pt>
+                  <c:pt idx="1">
+                    <c:v>Feb</c:v>
+                  </c:pt>
+                  <c:pt idx="2">
+                    <c:v>Mar</c:v>
+                  </c:pt>
+                  <c:pt idx="3">
+                    <c:v>Apr</c:v>
+                  </c:pt>
+                  <c:pt idx="4">
+                    <c:v>May</c:v>
+                  </c:pt>
+                  <c:pt idx="5">
+                    <c:v>Jun</c:v>
+                  </c:pt>
+                  <c:pt idx="6">
+                    <c:v>Jul</c:v>
+                  </c:pt>
+                  <c:pt idx="7">
+                    <c:v>Aug</c:v>
+                  </c:pt>
+                  <c:pt idx="8">
+                    <c:v>Sep</c:v>
+                  </c:pt>
+                  <c:pt idx="9">
+                    <c:v>Oct</c:v>
+                  </c:pt>
+                  <c:pt idx="10">
+                    <c:v>Nov</c:v>
+                  </c:pt>
+                  <c:pt idx="11">
+                    <c:v>Dec</c:v>
+                  </c:pt>
+                </c:lvl>
+              </c:multiLvlStrCache>
+            </c:multiLvlStrRef>
+          </c:cat>
+          <c:val>
+            <c:numRef>
+              <c:f>Sheet1!$B$2:$B$13</c:f>
+              <c:numCache>
+                <c:formatCode>General</c:formatCode>
+                <c:ptCount val="12"/>
+                <c:pt idx="0">
+                  <c:v>1625</c:v>
+                </c:pt>
+                <c:pt idx="1">
+                  <c:v>1632</c:v>
+                </c:pt>
+                <c:pt idx="2">
+                  <c:v>1629</c:v>
+                </c:pt>
+                <c:pt idx="3">
+                  <c:v>1615</c:v>
+                </c:pt>
+                <c:pt idx="4">
+                  <c:v>1623</c:v>
+                </c:pt>
+                <c:pt idx="5">
+                  <c:v>1616</c:v>
+                </c:pt>
+                <c:pt idx="6">
+                  <c:v>1629</c:v>
+                </c:pt>
+                <c:pt idx="7">
+                  <c:v>1627</c:v>
+                </c:pt>
+                <c:pt idx="8">
+                  <c:v>1616</c:v>
+                </c:pt>
+                <c:pt idx="9">
+                  <c:v>1604</c:v>
+                </c:pt>
+                <c:pt idx="10">
+                  <c:v>1582</c:v>
+                </c:pt>
+                <c:pt idx="11">
+                  <c:v>1563</c:v>
+                </c:pt>
+              </c:numCache>
+            </c:numRef>
+          </c:val>
+          <c:smooth val="0"/>
+        </c:ser>
+        <c:dLbls>
+          <c:numFmt formatCode="#,##0" sourceLinked="0"/>
+          <c:txPr>
+            <a:bodyPr/>
+            <a:lstStyle/>
+            <a:p>
+              <a:pPr>
+                <a:defRPr b="0" i="0" strike="noStrike" sz="1400" u="none">
+                  <a:solidFill>
+                    <a:srgbClr val="1A1A1A"/>
+                  </a:solidFill>
+                  <a:latin typeface="+mn-lt"/>
+                </a:defRPr>
+              </a:pPr>
+            </a:p>
+          </c:txPr>
+          <c:showLegendKey val="0"/>
+          <c:showVal val="0"/>
+          <c:showCatName val="0"/>
+          <c:showSerName val="0"/>
+          <c:showPercent val="0"/>
+          <c:showBubbleSize val="0"/>
+          <c:showLeaderLines val="0"/>
+        </c:dLbls>
+        <c:marker val="1"/>
+        <c:axId val="2094734554"/>
+        <c:axId val="2094734552"/>
+        <c:axId val="2094734556"/>
+      </c:lineChart>
+      <c:catAx>
+        <c:axId val="2094734554"/>
+        <c:scaling>
+          <c:orientation val="minMax"/>
+        </c:scaling>
+        <c:delete val="0"/>
+        <c:axPos val="b"/>
+        <c:numFmt formatCode="General" sourceLinked="1"/>
+        <c:majorTickMark val="out"/>
+        <c:minorTickMark val="none"/>
+        <c:tickLblPos val="low"/>
+        <c:spPr>
+          <a:ln w="12700" cap="flat">
             <a:solidFill>
               <a:srgbClr val="888888"/>
             </a:solidFill>
@@ -5037,7 +5959,7 @@
           </a:p>
         </c:txPr>
         <c:crossAx val="2094734552"/>
-        <c:crosses val="autoZero"/>
+        <c:crosses val="min"/>
         <c:auto val="1"/>
         <c:lblAlgn val="ctr"/>
         <c:noMultiLvlLbl val="1"/>
@@ -5046,8 +5968,8 @@
         <c:axId val="2094734552"/>
         <c:scaling>
           <c:orientation val="minMax"/>
-          <c:max val="1620"/>
-          <c:min val="1520"/>
+          <c:max val="1700"/>
+          <c:min val="1450"/>
         </c:scaling>
         <c:delete val="0"/>
         <c:axPos val="l"/>
@@ -5091,10 +6013,14 @@
         <c:crossAx val="2094734554"/>
         <c:crosses val="autoZero"/>
         <c:crossBetween val="between"/>
-        <c:majorUnit val="20"/>
+        <c:majorUnit val="50"/>
       </c:valAx>
       <c:spPr>
-        <a:noFill/>
+        <a:solidFill>
+          <a:srgbClr val="FFFFFF">
+            <a:alpha val="0"/>
+          </a:srgbClr>
+        </a:solidFill>
         <a:ln>
           <a:noFill/>
         </a:ln>
@@ -5105,7 +6031,11 @@
     <c:dispBlanksAs val="span"/>
   </c:chart>
   <c:spPr>
-    <a:noFill/>
+    <a:solidFill>
+      <a:srgbClr val="FFFFFF">
+        <a:alpha val="0"/>
+      </a:srgbClr>
+    </a:solidFill>
     <a:ln>
       <a:noFill/>
     </a:ln>
@@ -8131,7 +9061,7 @@
           <a:p>
             <a:r>
               <a:rPr lang="en-US" dirty="0"/>
-              <a:t>Source: Gross and ROs: Qlik - Productivity app (P&amp;L Total Gross Profit - Fixed Ops; CP &amp; W ROs). Headcount: ADP Employee Master extract, 10/19/2026, month-end snapshots, Qlik's fixed-employee title list. Each person counted once: someone open at two stores is counted at the old store until that record closes. Monthly averages, Jan-Sep. Same-store, INEOS excluded (opened 2026). GMC Prescott body shop gross, staff and body-only ROs excluded. Fixed employees include managers; technicians = service, express, foreman and team-leader titles.
+              <a:t>Source: Gross and ROs: Qlik - Productivity app (P&amp;L Total Gross Profit - Fixed Ops; CP &amp; W ROs). Headcount: ADP Employee Master extract, 10/19/2026, month-end snapshots, Qlik's fixed-employee title list. Each person counted once: someone open at two stores is counted at the old store until that record closes. Monthly averages, Jan-Sep. Same-store, INEOS excluded (opened 2026). GMC Prescott body shop gross, staff and body-only ROs excluded. YTD = average month-end fixed headcount, Jan-Sep. Fixed employees include managers; technicians = service, express, foreman and team-leader titles. 2025 shown January-December.
 Jan 25: 1625 fixed, 703 techs, 238 advisors, 117 managers
 Feb 25: 1632 fixed, 705 techs, 237 advisors, 116 managers
 Mar 25: 1629 fixed, 702 techs, 240 advisors, 116 managers
@@ -26107,7 +27037,7 @@
         <p:spPr>
           <a:xfrm>
             <a:off x="457200" y="1207008"/>
-            <a:ext cx="7589520" cy="4782312"/>
+            <a:ext cx="11274552" cy="1005840"/>
           </a:xfrm>
           <a:prstGeom prst="rect">
             <a:avLst/>
@@ -26126,8 +27056,8 @@
         </p:nvSpPr>
         <p:spPr>
           <a:xfrm>
-            <a:off x="685800" y="1344168"/>
-            <a:ext cx="7132320" cy="292608"/>
+            <a:off x="685800" y="1335024"/>
+            <a:ext cx="2651760" cy="237744"/>
           </a:xfrm>
           <a:prstGeom prst="rect">
             <a:avLst/>
@@ -26143,6 +27073,338 @@
               <a:buNone/>
             </a:pPr>
             <a:r>
+              <a:rPr lang="en-US" sz="1400" spc="90" kern="0" dirty="0">
+                <a:solidFill>
+                  <a:srgbClr val="595959"/>
+                </a:solidFill>
+                <a:latin typeface="Inter" pitchFamily="34" charset="0"/>
+                <a:ea typeface="Inter" pitchFamily="34" charset="-122"/>
+                <a:cs typeface="Inter" pitchFamily="34" charset="-120"/>
+              </a:rPr>
+              <a:t>2025 YTD</a:t>
+            </a:r>
+            <a:endParaRPr lang="en-US" sz="1400" dirty="0"/>
+          </a:p>
+        </p:txBody>
+      </p:sp>
+      <p:sp>
+        <p:nvSpPr>
+          <p:cNvPr id="7" name="Text 5"/>
+          <p:cNvSpPr txBox="1"/>
+          <p:nvPr/>
+        </p:nvSpPr>
+        <p:spPr>
+          <a:xfrm>
+            <a:off x="685800" y="1554480"/>
+            <a:ext cx="2697480" cy="548640"/>
+          </a:xfrm>
+          <a:prstGeom prst="rect">
+            <a:avLst/>
+          </a:prstGeom>
+          <a:noFill/>
+          <a:ln/>
+        </p:spPr>
+        <p:txBody>
+          <a:bodyPr wrap="square" lIns="0" tIns="0" rIns="0" bIns="0" rtlCol="0" anchor="ctr"/>
+          <a:lstStyle/>
+          <a:p>
+            <a:pPr indent="0" marL="0">
+              <a:buNone/>
+            </a:pPr>
+            <a:r>
+              <a:rPr lang="en-US" sz="3000" b="1" dirty="0">
+                <a:solidFill>
+                  <a:srgbClr val="1A1A1A"/>
+                </a:solidFill>
+                <a:latin typeface="Inter" pitchFamily="34" charset="0"/>
+                <a:ea typeface="Inter" pitchFamily="34" charset="-122"/>
+                <a:cs typeface="Inter" pitchFamily="34" charset="-120"/>
+              </a:rPr>
+              <a:t>1,624</a:t>
+            </a:r>
+            <a:endParaRPr lang="en-US" sz="3000" dirty="0"/>
+          </a:p>
+        </p:txBody>
+      </p:sp>
+      <p:sp>
+        <p:nvSpPr>
+          <p:cNvPr id="8" name="Text 6"/>
+          <p:cNvSpPr txBox="1"/>
+          <p:nvPr/>
+        </p:nvSpPr>
+        <p:spPr>
+          <a:xfrm>
+            <a:off x="3474720" y="1335024"/>
+            <a:ext cx="2651760" cy="237744"/>
+          </a:xfrm>
+          <a:prstGeom prst="rect">
+            <a:avLst/>
+          </a:prstGeom>
+          <a:noFill/>
+          <a:ln/>
+        </p:spPr>
+        <p:txBody>
+          <a:bodyPr wrap="square" lIns="0" tIns="0" rIns="0" bIns="0" rtlCol="0" anchor="ctr"/>
+          <a:lstStyle/>
+          <a:p>
+            <a:pPr indent="0" marL="0">
+              <a:buNone/>
+            </a:pPr>
+            <a:r>
+              <a:rPr lang="en-US" sz="1400" spc="90" kern="0" dirty="0">
+                <a:solidFill>
+                  <a:srgbClr val="595959"/>
+                </a:solidFill>
+                <a:latin typeface="Inter" pitchFamily="34" charset="0"/>
+                <a:ea typeface="Inter" pitchFamily="34" charset="-122"/>
+                <a:cs typeface="Inter" pitchFamily="34" charset="-120"/>
+              </a:rPr>
+              <a:t>2026 YTD</a:t>
+            </a:r>
+            <a:endParaRPr lang="en-US" sz="1400" dirty="0"/>
+          </a:p>
+        </p:txBody>
+      </p:sp>
+      <p:sp>
+        <p:nvSpPr>
+          <p:cNvPr id="9" name="Text 7"/>
+          <p:cNvSpPr txBox="1"/>
+          <p:nvPr/>
+        </p:nvSpPr>
+        <p:spPr>
+          <a:xfrm>
+            <a:off x="3474720" y="1554480"/>
+            <a:ext cx="2697480" cy="548640"/>
+          </a:xfrm>
+          <a:prstGeom prst="rect">
+            <a:avLst/>
+          </a:prstGeom>
+          <a:noFill/>
+          <a:ln/>
+        </p:spPr>
+        <p:txBody>
+          <a:bodyPr wrap="square" lIns="0" tIns="0" rIns="0" bIns="0" rtlCol="0" anchor="ctr"/>
+          <a:lstStyle/>
+          <a:p>
+            <a:pPr indent="0" marL="0">
+              <a:buNone/>
+            </a:pPr>
+            <a:r>
+              <a:rPr lang="en-US" sz="3000" b="1" dirty="0">
+                <a:solidFill>
+                  <a:srgbClr val="1A1A1A"/>
+                </a:solidFill>
+                <a:latin typeface="Inter" pitchFamily="34" charset="0"/>
+                <a:ea typeface="Inter" pitchFamily="34" charset="-122"/>
+                <a:cs typeface="Inter" pitchFamily="34" charset="-120"/>
+              </a:rPr>
+              <a:t>1,541</a:t>
+            </a:r>
+            <a:endParaRPr lang="en-US" sz="3000" dirty="0"/>
+          </a:p>
+        </p:txBody>
+      </p:sp>
+      <p:sp>
+        <p:nvSpPr>
+          <p:cNvPr id="10" name="Text 8"/>
+          <p:cNvSpPr txBox="1"/>
+          <p:nvPr/>
+        </p:nvSpPr>
+        <p:spPr>
+          <a:xfrm>
+            <a:off x="6263640" y="1335024"/>
+            <a:ext cx="2651760" cy="237744"/>
+          </a:xfrm>
+          <a:prstGeom prst="rect">
+            <a:avLst/>
+          </a:prstGeom>
+          <a:noFill/>
+          <a:ln/>
+        </p:spPr>
+        <p:txBody>
+          <a:bodyPr wrap="square" lIns="0" tIns="0" rIns="0" bIns="0" rtlCol="0" anchor="ctr"/>
+          <a:lstStyle/>
+          <a:p>
+            <a:pPr indent="0" marL="0">
+              <a:buNone/>
+            </a:pPr>
+            <a:r>
+              <a:rPr lang="en-US" sz="1400" spc="90" kern="0" dirty="0">
+                <a:solidFill>
+                  <a:srgbClr val="595959"/>
+                </a:solidFill>
+                <a:latin typeface="Inter" pitchFamily="34" charset="0"/>
+                <a:ea typeface="Inter" pitchFamily="34" charset="-122"/>
+                <a:cs typeface="Inter" pitchFamily="34" charset="-120"/>
+              </a:rPr>
+              <a:t>VARIANCE</a:t>
+            </a:r>
+            <a:endParaRPr lang="en-US" sz="1400" dirty="0"/>
+          </a:p>
+        </p:txBody>
+      </p:sp>
+      <p:sp>
+        <p:nvSpPr>
+          <p:cNvPr id="11" name="Text 9"/>
+          <p:cNvSpPr txBox="1"/>
+          <p:nvPr/>
+        </p:nvSpPr>
+        <p:spPr>
+          <a:xfrm>
+            <a:off x="6263640" y="1554480"/>
+            <a:ext cx="2697480" cy="548640"/>
+          </a:xfrm>
+          <a:prstGeom prst="rect">
+            <a:avLst/>
+          </a:prstGeom>
+          <a:noFill/>
+          <a:ln/>
+        </p:spPr>
+        <p:txBody>
+          <a:bodyPr wrap="square" lIns="0" tIns="0" rIns="0" bIns="0" rtlCol="0" anchor="ctr"/>
+          <a:lstStyle/>
+          <a:p>
+            <a:pPr indent="0" marL="0">
+              <a:buNone/>
+            </a:pPr>
+            <a:r>
+              <a:rPr lang="en-US" sz="3000" b="1" dirty="0">
+                <a:solidFill>
+                  <a:srgbClr val="0B2C4A"/>
+                </a:solidFill>
+                <a:latin typeface="Inter" pitchFamily="34" charset="0"/>
+                <a:ea typeface="Inter" pitchFamily="34" charset="-122"/>
+                <a:cs typeface="Inter" pitchFamily="34" charset="-120"/>
+              </a:rPr>
+              <a:t>−83</a:t>
+            </a:r>
+            <a:endParaRPr lang="en-US" sz="3000" dirty="0"/>
+          </a:p>
+        </p:txBody>
+      </p:sp>
+      <p:sp>
+        <p:nvSpPr>
+          <p:cNvPr id="12" name="Text 10"/>
+          <p:cNvSpPr txBox="1"/>
+          <p:nvPr/>
+        </p:nvSpPr>
+        <p:spPr>
+          <a:xfrm>
+            <a:off x="9052560" y="1335024"/>
+            <a:ext cx="2651760" cy="237744"/>
+          </a:xfrm>
+          <a:prstGeom prst="rect">
+            <a:avLst/>
+          </a:prstGeom>
+          <a:noFill/>
+          <a:ln/>
+        </p:spPr>
+        <p:txBody>
+          <a:bodyPr wrap="square" lIns="0" tIns="0" rIns="0" bIns="0" rtlCol="0" anchor="ctr"/>
+          <a:lstStyle/>
+          <a:p>
+            <a:pPr indent="0" marL="0">
+              <a:buNone/>
+            </a:pPr>
+            <a:r>
+              <a:rPr lang="en-US" sz="1400" spc="90" kern="0" dirty="0">
+                <a:solidFill>
+                  <a:srgbClr val="595959"/>
+                </a:solidFill>
+                <a:latin typeface="Inter" pitchFamily="34" charset="0"/>
+                <a:ea typeface="Inter" pitchFamily="34" charset="-122"/>
+                <a:cs typeface="Inter" pitchFamily="34" charset="-120"/>
+              </a:rPr>
+              <a:t>VAR %</a:t>
+            </a:r>
+            <a:endParaRPr lang="en-US" sz="1400" dirty="0"/>
+          </a:p>
+        </p:txBody>
+      </p:sp>
+      <p:sp>
+        <p:nvSpPr>
+          <p:cNvPr id="13" name="Text 11"/>
+          <p:cNvSpPr txBox="1"/>
+          <p:nvPr/>
+        </p:nvSpPr>
+        <p:spPr>
+          <a:xfrm>
+            <a:off x="9052560" y="1554480"/>
+            <a:ext cx="2697480" cy="548640"/>
+          </a:xfrm>
+          <a:prstGeom prst="rect">
+            <a:avLst/>
+          </a:prstGeom>
+          <a:noFill/>
+          <a:ln/>
+        </p:spPr>
+        <p:txBody>
+          <a:bodyPr wrap="square" lIns="0" tIns="0" rIns="0" bIns="0" rtlCol="0" anchor="ctr"/>
+          <a:lstStyle/>
+          <a:p>
+            <a:pPr indent="0" marL="0">
+              <a:buNone/>
+            </a:pPr>
+            <a:r>
+              <a:rPr lang="en-US" sz="3000" b="1" dirty="0">
+                <a:solidFill>
+                  <a:srgbClr val="0B2C4A"/>
+                </a:solidFill>
+                <a:latin typeface="Inter" pitchFamily="34" charset="0"/>
+                <a:ea typeface="Inter" pitchFamily="34" charset="-122"/>
+                <a:cs typeface="Inter" pitchFamily="34" charset="-120"/>
+              </a:rPr>
+              <a:t>−5.1%</a:t>
+            </a:r>
+            <a:endParaRPr lang="en-US" sz="3000" dirty="0"/>
+          </a:p>
+        </p:txBody>
+      </p:sp>
+      <p:sp>
+        <p:nvSpPr>
+          <p:cNvPr id="14" name="Shape 12"/>
+          <p:cNvSpPr/>
+          <p:nvPr/>
+        </p:nvSpPr>
+        <p:spPr>
+          <a:xfrm>
+            <a:off x="457200" y="2322576"/>
+            <a:ext cx="11274552" cy="3666744"/>
+          </a:xfrm>
+          <a:prstGeom prst="rect">
+            <a:avLst/>
+          </a:prstGeom>
+          <a:solidFill>
+            <a:srgbClr val="FFFFFF"/>
+          </a:solidFill>
+          <a:ln/>
+        </p:spPr>
+      </p:sp>
+      <p:sp>
+        <p:nvSpPr>
+          <p:cNvPr id="15" name="Text 13"/>
+          <p:cNvSpPr txBox="1"/>
+          <p:nvPr/>
+        </p:nvSpPr>
+        <p:spPr>
+          <a:xfrm>
+            <a:off x="685800" y="2459736"/>
+            <a:ext cx="10817352" cy="292608"/>
+          </a:xfrm>
+          <a:prstGeom prst="rect">
+            <a:avLst/>
+          </a:prstGeom>
+          <a:noFill/>
+          <a:ln/>
+        </p:spPr>
+        <p:txBody>
+          <a:bodyPr wrap="square" lIns="0" tIns="0" rIns="0" bIns="0" rtlCol="0" anchor="ctr"/>
+          <a:lstStyle/>
+          <a:p>
+            <a:pPr indent="0" marL="0">
+              <a:buNone/>
+            </a:pPr>
+            <a:r>
               <a:rPr lang="en-US" sz="1500" dirty="0">
                 <a:solidFill>
                   <a:srgbClr val="1A1A1A"/>
@@ -26151,7 +27413,7 @@
                 <a:ea typeface="Inter" pitchFamily="34" charset="-122"/>
                 <a:cs typeface="Inter" pitchFamily="34" charset="-120"/>
               </a:rPr>
-              <a:t>Fixed employees, trailing 12 months</a:t>
+              <a:t>Fixed employees at month end, 2025 against 2026</a:t>
             </a:r>
             <a:endParaRPr lang="en-US" sz="1500" dirty="0"/>
           </a:p>
@@ -26159,14 +27421,14 @@
       </p:sp>
       <p:sp>
         <p:nvSpPr>
-          <p:cNvPr id="7" name="Shape 5"/>
+          <p:cNvPr id="16" name="Shape 14"/>
           <p:cNvSpPr/>
           <p:nvPr/>
         </p:nvSpPr>
         <p:spPr>
           <a:xfrm>
-            <a:off x="685800" y="1691640"/>
-            <a:ext cx="7132320" cy="10973"/>
+            <a:off x="685800" y="2807208"/>
+            <a:ext cx="10817352" cy="10973"/>
           </a:xfrm>
           <a:prstGeom prst="rect">
             <a:avLst/>
@@ -26179,13 +27441,13 @@
       </p:sp>
       <p:graphicFrame>
         <p:nvGraphicFramePr>
-          <p:cNvPr id="8" name="Chart 0" descr=""/>
+          <p:cNvPr id="17" name="Chart 0" descr=""/>
           <p:cNvGraphicFramePr/>
           <p:nvPr/>
         </p:nvGraphicFramePr>
         <p:xfrm>
-          <a:off x="621792" y="1810512"/>
-          <a:ext cx="6858000" cy="4023360"/>
+          <a:off x="621792" y="3218688"/>
+          <a:ext cx="10945368" cy="2679192"/>
         </p:xfrm>
         <a:graphic xmlns:a="http://schemas.openxmlformats.org/drawingml/2006/main">
           <a:graphicData uri="http://schemas.openxmlformats.org/drawingml/2006/chart">
@@ -26193,36 +27455,104 @@
           </a:graphicData>
         </a:graphic>
       </p:graphicFrame>
-      <p:sp>
-        <p:nvSpPr>
-          <p:cNvPr id="9" name="Shape 6"/>
+      <p:graphicFrame>
+        <p:nvGraphicFramePr>
+          <p:cNvPr id="18" name="Chart 1" descr=""/>
+          <p:cNvGraphicFramePr/>
+          <p:nvPr/>
+        </p:nvGraphicFramePr>
+        <p:xfrm>
+          <a:off x="621792" y="3218688"/>
+          <a:ext cx="10945368" cy="2679192"/>
+        </p:xfrm>
+        <a:graphic xmlns:a="http://schemas.openxmlformats.org/drawingml/2006/main">
+          <a:graphicData uri="http://schemas.openxmlformats.org/drawingml/2006/chart">
+            <c:chart xmlns:c="http://schemas.openxmlformats.org/drawingml/2006/chart" r:id="rId2"/>
+          </a:graphicData>
+        </a:graphic>
+      </p:graphicFrame>
+      <p:graphicFrame>
+        <p:nvGraphicFramePr>
+          <p:cNvPr id="19" name="Chart 2" descr=""/>
+          <p:cNvGraphicFramePr/>
+          <p:nvPr/>
+        </p:nvGraphicFramePr>
+        <p:xfrm>
+          <a:off x="621792" y="3218688"/>
+          <a:ext cx="10945368" cy="2679192"/>
+        </p:xfrm>
+        <a:graphic xmlns:a="http://schemas.openxmlformats.org/drawingml/2006/main">
+          <a:graphicData uri="http://schemas.openxmlformats.org/drawingml/2006/chart">
+            <c:chart xmlns:c="http://schemas.openxmlformats.org/drawingml/2006/chart" r:id="rId3"/>
+          </a:graphicData>
+        </a:graphic>
+      </p:graphicFrame>
+      <p:graphicFrame>
+        <p:nvGraphicFramePr>
+          <p:cNvPr id="20" name="Chart 3" descr=""/>
+          <p:cNvGraphicFramePr/>
+          <p:nvPr/>
+        </p:nvGraphicFramePr>
+        <p:xfrm>
+          <a:off x="621792" y="3218688"/>
+          <a:ext cx="10945368" cy="2679192"/>
+        </p:xfrm>
+        <a:graphic xmlns:a="http://schemas.openxmlformats.org/drawingml/2006/main">
+          <a:graphicData uri="http://schemas.openxmlformats.org/drawingml/2006/chart">
+            <c:chart xmlns:c="http://schemas.openxmlformats.org/drawingml/2006/chart" r:id="rId4"/>
+          </a:graphicData>
+        </a:graphic>
+      </p:graphicFrame>
+      <p:sp>
+        <p:nvSpPr>
+          <p:cNvPr id="21" name="Shape 15"/>
           <p:cNvSpPr/>
           <p:nvPr/>
         </p:nvSpPr>
         <p:spPr>
           <a:xfrm>
-            <a:off x="8229600" y="1207008"/>
-            <a:ext cx="3502152" cy="4782312"/>
+            <a:off x="4951476" y="3049524"/>
+            <a:ext cx="310896" cy="45720"/>
           </a:xfrm>
           <a:prstGeom prst="rect">
             <a:avLst/>
           </a:prstGeom>
           <a:solidFill>
-            <a:srgbClr val="FFFFFF"/>
+            <a:srgbClr val="9AA3AD"/>
           </a:solidFill>
           <a:ln/>
         </p:spPr>
       </p:sp>
       <p:sp>
         <p:nvSpPr>
-          <p:cNvPr id="10" name="Text 7"/>
-          <p:cNvSpPr txBox="1"/>
-          <p:nvPr/>
-        </p:nvSpPr>
-        <p:spPr>
-          <a:xfrm>
-            <a:off x="8458200" y="1344168"/>
-            <a:ext cx="3044952" cy="292608"/>
+          <p:cNvPr id="22" name="Shape 16"/>
+          <p:cNvSpPr/>
+          <p:nvPr/>
+        </p:nvSpPr>
+        <p:spPr>
+          <a:xfrm>
+            <a:off x="5052060" y="3017520"/>
+            <a:ext cx="109728" cy="109728"/>
+          </a:xfrm>
+          <a:prstGeom prst="ellipse">
+            <a:avLst/>
+          </a:prstGeom>
+          <a:solidFill>
+            <a:srgbClr val="9AA3AD"/>
+          </a:solidFill>
+          <a:ln/>
+        </p:spPr>
+      </p:sp>
+      <p:sp>
+        <p:nvSpPr>
+          <p:cNvPr id="23" name="Text 17"/>
+          <p:cNvSpPr txBox="1"/>
+          <p:nvPr/>
+        </p:nvSpPr>
+        <p:spPr>
+          <a:xfrm>
+            <a:off x="5335524" y="2926080"/>
+            <a:ext cx="777240" cy="292608"/>
           </a:xfrm>
           <a:prstGeom prst="rect">
             <a:avLst/>
@@ -26238,7 +27568,7 @@
               <a:buNone/>
             </a:pPr>
             <a:r>
-              <a:rPr lang="en-US" sz="1500" dirty="0">
+              <a:rPr lang="en-US" sz="1400" dirty="0">
                 <a:solidFill>
                   <a:srgbClr val="1A1A1A"/>
                 </a:solidFill>
@@ -26246,44 +27576,24 @@
                 <a:ea typeface="Inter" pitchFamily="34" charset="-122"/>
                 <a:cs typeface="Inter" pitchFamily="34" charset="-120"/>
               </a:rPr>
-              <a:t>What it says</a:t>
-            </a:r>
-            <a:endParaRPr lang="en-US" sz="1500" dirty="0"/>
-          </a:p>
-        </p:txBody>
-      </p:sp>
-      <p:sp>
-        <p:nvSpPr>
-          <p:cNvPr id="11" name="Shape 8"/>
+              <a:t>2025</a:t>
+            </a:r>
+            <a:endParaRPr lang="en-US" sz="1400" dirty="0"/>
+          </a:p>
+        </p:txBody>
+      </p:sp>
+      <p:sp>
+        <p:nvSpPr>
+          <p:cNvPr id="24" name="Shape 18"/>
           <p:cNvSpPr/>
           <p:nvPr/>
         </p:nvSpPr>
         <p:spPr>
           <a:xfrm>
-            <a:off x="8458200" y="1691640"/>
-            <a:ext cx="3044952" cy="10973"/>
-          </a:xfrm>
-          <a:prstGeom prst="rect">
-            <a:avLst/>
-          </a:prstGeom>
-          <a:solidFill>
-            <a:srgbClr val="1A1A1A"/>
-          </a:solidFill>
-          <a:ln/>
-        </p:spPr>
-      </p:sp>
-      <p:sp>
-        <p:nvSpPr>
-          <p:cNvPr id="12" name="Shape 9"/>
-          <p:cNvSpPr/>
-          <p:nvPr/>
-        </p:nvSpPr>
-        <p:spPr>
-          <a:xfrm>
-            <a:off x="8458200" y="1938528"/>
-            <a:ext cx="100584" cy="100584"/>
-          </a:xfrm>
-          <a:prstGeom prst="ellipse">
+            <a:off x="6185916" y="3049524"/>
+            <a:ext cx="310896" cy="45720"/>
+          </a:xfrm>
+          <a:prstGeom prst="rect">
             <a:avLst/>
           </a:prstGeom>
           <a:solidFill>
@@ -26294,89 +27604,50 @@
       </p:sp>
       <p:sp>
         <p:nvSpPr>
-          <p:cNvPr id="13" name="Text 10"/>
-          <p:cNvSpPr txBox="1"/>
-          <p:nvPr/>
-        </p:nvSpPr>
-        <p:spPr>
-          <a:xfrm>
-            <a:off x="8705088" y="1810512"/>
-            <a:ext cx="2834640" cy="1051560"/>
-          </a:xfrm>
-          <a:prstGeom prst="rect">
-            <a:avLst/>
-          </a:prstGeom>
-          <a:noFill/>
-          <a:ln/>
-        </p:spPr>
-        <p:txBody>
-          <a:bodyPr wrap="square" lIns="0" tIns="0" rIns="0" bIns="0" rtlCol="0" anchor="t"/>
+          <p:cNvPr id="25" name="Shape 19"/>
+          <p:cNvSpPr/>
+          <p:nvPr/>
+        </p:nvSpPr>
+        <p:spPr>
+          <a:xfrm>
+            <a:off x="6286500" y="3017520"/>
+            <a:ext cx="109728" cy="109728"/>
+          </a:xfrm>
+          <a:prstGeom prst="ellipse">
+            <a:avLst/>
+          </a:prstGeom>
+          <a:solidFill>
+            <a:srgbClr val="2587C5"/>
+          </a:solidFill>
+          <a:ln/>
+        </p:spPr>
+      </p:sp>
+      <p:sp>
+        <p:nvSpPr>
+          <p:cNvPr id="26" name="Text 20"/>
+          <p:cNvSpPr txBox="1"/>
+          <p:nvPr/>
+        </p:nvSpPr>
+        <p:spPr>
+          <a:xfrm>
+            <a:off x="6569964" y="2926080"/>
+            <a:ext cx="777240" cy="292608"/>
+          </a:xfrm>
+          <a:prstGeom prst="rect">
+            <a:avLst/>
+          </a:prstGeom>
+          <a:noFill/>
+          <a:ln/>
+        </p:spPr>
+        <p:txBody>
+          <a:bodyPr wrap="square" lIns="0" tIns="0" rIns="0" bIns="0" rtlCol="0" anchor="ctr"/>
           <a:lstStyle/>
           <a:p>
             <a:pPr indent="0" marL="0">
               <a:buNone/>
             </a:pPr>
             <a:r>
-              <a:rPr lang="en-US" sz="1500" b="1" dirty="0">
-                <a:solidFill>
-                  <a:srgbClr val="2587C5"/>
-                </a:solidFill>
-                <a:latin typeface="Inter" pitchFamily="34" charset="0"/>
-                <a:ea typeface="Inter" pitchFamily="34" charset="-122"/>
-                <a:cs typeface="Inter" pitchFamily="34" charset="-120"/>
-              </a:rPr>
-              <a:t>−76 fixed staff, Sep to Sep, to 1,540.</a:t>
-            </a:r>
-            <a:endParaRPr lang="en-US" sz="1500" dirty="0"/>
-          </a:p>
-        </p:txBody>
-      </p:sp>
-      <p:sp>
-        <p:nvSpPr>
-          <p:cNvPr id="14" name="Shape 11"/>
-          <p:cNvSpPr/>
-          <p:nvPr/>
-        </p:nvSpPr>
-        <p:spPr>
-          <a:xfrm>
-            <a:off x="8458200" y="3072384"/>
-            <a:ext cx="100584" cy="100584"/>
-          </a:xfrm>
-          <a:prstGeom prst="ellipse">
-            <a:avLst/>
-          </a:prstGeom>
-          <a:solidFill>
-            <a:srgbClr val="1A1A1A"/>
-          </a:solidFill>
-          <a:ln/>
-        </p:spPr>
-      </p:sp>
-      <p:sp>
-        <p:nvSpPr>
-          <p:cNvPr id="15" name="Text 12"/>
-          <p:cNvSpPr txBox="1"/>
-          <p:nvPr/>
-        </p:nvSpPr>
-        <p:spPr>
-          <a:xfrm>
-            <a:off x="8705088" y="2944368"/>
-            <a:ext cx="2834640" cy="1051560"/>
-          </a:xfrm>
-          <a:prstGeom prst="rect">
-            <a:avLst/>
-          </a:prstGeom>
-          <a:noFill/>
-          <a:ln/>
-        </p:spPr>
-        <p:txBody>
-          <a:bodyPr wrap="square" lIns="0" tIns="0" rIns="0" bIns="0" rtlCol="0" anchor="t"/>
-          <a:lstStyle/>
-          <a:p>
-            <a:pPr indent="0" marL="0">
-              <a:buNone/>
-            </a:pPr>
-            <a:r>
-              <a:rPr lang="en-US" sz="1500" dirty="0">
+              <a:rPr lang="en-US" sz="1400" dirty="0">
                 <a:solidFill>
                   <a:srgbClr val="1A1A1A"/>
                 </a:solidFill>
@@ -26384,74 +27655,15 @@
                 <a:ea typeface="Inter" pitchFamily="34" charset="-122"/>
                 <a:cs typeface="Inter" pitchFamily="34" charset="-120"/>
               </a:rPr>
-              <a:t>Technicians −17, advisors −7, managers −3.</a:t>
-            </a:r>
-            <a:endParaRPr lang="en-US" sz="1500" dirty="0"/>
-          </a:p>
-        </p:txBody>
-      </p:sp>
-      <p:sp>
-        <p:nvSpPr>
-          <p:cNvPr id="16" name="Shape 13"/>
-          <p:cNvSpPr/>
-          <p:nvPr/>
-        </p:nvSpPr>
-        <p:spPr>
-          <a:xfrm>
-            <a:off x="8458200" y="4206240"/>
-            <a:ext cx="100584" cy="100584"/>
-          </a:xfrm>
-          <a:prstGeom prst="ellipse">
-            <a:avLst/>
-          </a:prstGeom>
-          <a:solidFill>
-            <a:srgbClr val="1A1A1A"/>
-          </a:solidFill>
-          <a:ln/>
-        </p:spPr>
-      </p:sp>
-      <p:sp>
-        <p:nvSpPr>
-          <p:cNvPr id="17" name="Text 14"/>
-          <p:cNvSpPr txBox="1"/>
-          <p:nvPr/>
-        </p:nvSpPr>
-        <p:spPr>
-          <a:xfrm>
-            <a:off x="8705088" y="4078224"/>
-            <a:ext cx="2834640" cy="1051560"/>
-          </a:xfrm>
-          <a:prstGeom prst="rect">
-            <a:avLst/>
-          </a:prstGeom>
-          <a:noFill/>
-          <a:ln/>
-        </p:spPr>
-        <p:txBody>
-          <a:bodyPr wrap="square" lIns="0" tIns="0" rIns="0" bIns="0" rtlCol="0" anchor="t"/>
-          <a:lstStyle/>
-          <a:p>
-            <a:pPr indent="0" marL="0">
-              <a:buNone/>
-            </a:pPr>
-            <a:r>
-              <a:rPr lang="en-US" sz="1500" dirty="0">
-                <a:solidFill>
-                  <a:srgbClr val="1A1A1A"/>
-                </a:solidFill>
-                <a:latin typeface="Inter" pitchFamily="34" charset="0"/>
-                <a:ea typeface="Inter" pitchFamily="34" charset="-122"/>
-                <a:cs typeface="Inter" pitchFamily="34" charset="-120"/>
-              </a:rPr>
-              <a:t>Low of 1,530 in Jan 26; up 10 since.</a:t>
-            </a:r>
-            <a:endParaRPr lang="en-US" sz="1500" dirty="0"/>
-          </a:p>
-        </p:txBody>
-      </p:sp>
-      <p:sp>
-        <p:nvSpPr>
-          <p:cNvPr id="18" name="Shape 15"/>
+              <a:t>2026</a:t>
+            </a:r>
+            <a:endParaRPr lang="en-US" sz="1400" dirty="0"/>
+          </a:p>
+        </p:txBody>
+      </p:sp>
+      <p:sp>
+        <p:nvSpPr>
+          <p:cNvPr id="27" name="Shape 21"/>
           <p:cNvSpPr/>
           <p:nvPr/>
         </p:nvSpPr>
@@ -26471,7 +27683,7 @@
       </p:sp>
       <p:sp>
         <p:nvSpPr>
-          <p:cNvPr id="19" name="Text 16"/>
+          <p:cNvPr id="28" name="Text 22"/>
           <p:cNvSpPr txBox="1"/>
           <p:nvPr/>
         </p:nvSpPr>

</xml_diff>